<commit_message>
aggiornamento Presentazione gruppo Majo - Food Alchemy.pptx
</commit_message>
<xml_diff>
--- a/documentazione/Presentazione gruppo Majo - Food Alchemy.pptx
+++ b/documentazione/Presentazione gruppo Majo - Food Alchemy.pptx
@@ -106,6 +106,11 @@
       </a:defRPr>
     </a:lvl9pPr>
   </p:defaultTextStyle>
+  <p:extLst>
+    <p:ext uri="{EFAFB233-063F-42B5-8137-9DF3F51BA10A}">
+      <p15:sldGuideLst xmlns:p15="http://schemas.microsoft.com/office/powerpoint/2012/main"/>
+    </p:ext>
+  </p:extLst>
 </p:presentation>
 </file>
 
@@ -256,7 +261,7 @@
           <a:p>
             <a:fld id="{27026B27-F439-4400-84D8-562DFEFE8515}" type="datetimeFigureOut">
               <a:rPr lang="it-IT" smtClean="0"/>
-              <a:t>03/02/2024</a:t>
+              <a:t>04/02/2024</a:t>
             </a:fld>
             <a:endParaRPr lang="it-IT"/>
           </a:p>
@@ -454,7 +459,7 @@
           <a:p>
             <a:fld id="{27026B27-F439-4400-84D8-562DFEFE8515}" type="datetimeFigureOut">
               <a:rPr lang="it-IT" smtClean="0"/>
-              <a:t>03/02/2024</a:t>
+              <a:t>04/02/2024</a:t>
             </a:fld>
             <a:endParaRPr lang="it-IT"/>
           </a:p>
@@ -662,7 +667,7 @@
           <a:p>
             <a:fld id="{27026B27-F439-4400-84D8-562DFEFE8515}" type="datetimeFigureOut">
               <a:rPr lang="it-IT" smtClean="0"/>
-              <a:t>03/02/2024</a:t>
+              <a:t>04/02/2024</a:t>
             </a:fld>
             <a:endParaRPr lang="it-IT"/>
           </a:p>
@@ -860,7 +865,7 @@
           <a:p>
             <a:fld id="{27026B27-F439-4400-84D8-562DFEFE8515}" type="datetimeFigureOut">
               <a:rPr lang="it-IT" smtClean="0"/>
-              <a:t>03/02/2024</a:t>
+              <a:t>04/02/2024</a:t>
             </a:fld>
             <a:endParaRPr lang="it-IT"/>
           </a:p>
@@ -1135,7 +1140,7 @@
           <a:p>
             <a:fld id="{27026B27-F439-4400-84D8-562DFEFE8515}" type="datetimeFigureOut">
               <a:rPr lang="it-IT" smtClean="0"/>
-              <a:t>03/02/2024</a:t>
+              <a:t>04/02/2024</a:t>
             </a:fld>
             <a:endParaRPr lang="it-IT"/>
           </a:p>
@@ -1400,7 +1405,7 @@
           <a:p>
             <a:fld id="{27026B27-F439-4400-84D8-562DFEFE8515}" type="datetimeFigureOut">
               <a:rPr lang="it-IT" smtClean="0"/>
-              <a:t>03/02/2024</a:t>
+              <a:t>04/02/2024</a:t>
             </a:fld>
             <a:endParaRPr lang="it-IT"/>
           </a:p>
@@ -1812,7 +1817,7 @@
           <a:p>
             <a:fld id="{27026B27-F439-4400-84D8-562DFEFE8515}" type="datetimeFigureOut">
               <a:rPr lang="it-IT" smtClean="0"/>
-              <a:t>03/02/2024</a:t>
+              <a:t>04/02/2024</a:t>
             </a:fld>
             <a:endParaRPr lang="it-IT"/>
           </a:p>
@@ -1953,7 +1958,7 @@
           <a:p>
             <a:fld id="{27026B27-F439-4400-84D8-562DFEFE8515}" type="datetimeFigureOut">
               <a:rPr lang="it-IT" smtClean="0"/>
-              <a:t>03/02/2024</a:t>
+              <a:t>04/02/2024</a:t>
             </a:fld>
             <a:endParaRPr lang="it-IT"/>
           </a:p>
@@ -2066,7 +2071,7 @@
           <a:p>
             <a:fld id="{27026B27-F439-4400-84D8-562DFEFE8515}" type="datetimeFigureOut">
               <a:rPr lang="it-IT" smtClean="0"/>
-              <a:t>03/02/2024</a:t>
+              <a:t>04/02/2024</a:t>
             </a:fld>
             <a:endParaRPr lang="it-IT"/>
           </a:p>
@@ -2377,7 +2382,7 @@
           <a:p>
             <a:fld id="{27026B27-F439-4400-84D8-562DFEFE8515}" type="datetimeFigureOut">
               <a:rPr lang="it-IT" smtClean="0"/>
-              <a:t>03/02/2024</a:t>
+              <a:t>04/02/2024</a:t>
             </a:fld>
             <a:endParaRPr lang="it-IT"/>
           </a:p>
@@ -2665,7 +2670,7 @@
           <a:p>
             <a:fld id="{27026B27-F439-4400-84D8-562DFEFE8515}" type="datetimeFigureOut">
               <a:rPr lang="it-IT" smtClean="0"/>
-              <a:t>03/02/2024</a:t>
+              <a:t>04/02/2024</a:t>
             </a:fld>
             <a:endParaRPr lang="it-IT"/>
           </a:p>
@@ -2906,7 +2911,7 @@
           <a:p>
             <a:fld id="{27026B27-F439-4400-84D8-562DFEFE8515}" type="datetimeFigureOut">
               <a:rPr lang="it-IT" smtClean="0"/>
-              <a:t>03/02/2024</a:t>
+              <a:t>04/02/2024</a:t>
             </a:fld>
             <a:endParaRPr lang="it-IT"/>
           </a:p>
@@ -5356,41 +5361,6 @@
           </a:p>
         </p:txBody>
       </p:sp>
-      <p:pic>
-        <p:nvPicPr>
-          <p:cNvPr id="16" name="Segnaposto contenuto 15" descr="Immagine che contiene testo, schermata, diagramma, design&#10;&#10;Descrizione generata automaticamente">
-            <a:extLst>
-              <a:ext uri="{FF2B5EF4-FFF2-40B4-BE49-F238E27FC236}">
-                <a16:creationId xmlns:a16="http://schemas.microsoft.com/office/drawing/2014/main" id="{0CDC2341-E359-3B91-5201-09DD1935B914}"/>
-              </a:ext>
-            </a:extLst>
-          </p:cNvPr>
-          <p:cNvPicPr>
-            <a:picLocks noGrp="1" noChangeAspect="1"/>
-          </p:cNvPicPr>
-          <p:nvPr>
-            <p:ph idx="1"/>
-          </p:nvPr>
-        </p:nvPicPr>
-        <p:blipFill>
-          <a:blip r:embed="rId2">
-            <a:extLst>
-              <a:ext uri="{28A0092B-C50C-407E-A947-70E740481C1C}">
-                <a14:useLocalDpi xmlns:a14="http://schemas.microsoft.com/office/drawing/2010/main" val="0"/>
-              </a:ext>
-            </a:extLst>
-          </a:blip>
-          <a:stretch>
-            <a:fillRect/>
-          </a:stretch>
-        </p:blipFill>
-        <p:spPr>
-          <a:xfrm>
-            <a:off x="4250399" y="65323"/>
-            <a:ext cx="5156710" cy="6727353"/>
-          </a:xfrm>
-        </p:spPr>
-      </p:pic>
       <p:sp>
         <p:nvSpPr>
           <p:cNvPr id="18" name="CasellaDiTesto 17">
@@ -5456,6 +5426,41 @@
           </a:p>
         </p:txBody>
       </p:sp>
+      <p:pic>
+        <p:nvPicPr>
+          <p:cNvPr id="6" name="Segnaposto contenuto 5" descr="Immagine che contiene testo, schermata, diagramma, design&#10;&#10;Descrizione generata automaticamente">
+            <a:extLst>
+              <a:ext uri="{FF2B5EF4-FFF2-40B4-BE49-F238E27FC236}">
+                <a16:creationId xmlns:a16="http://schemas.microsoft.com/office/drawing/2014/main" id="{4E81736F-3032-CD7A-ECBF-1D7C1ABBDAFB}"/>
+              </a:ext>
+            </a:extLst>
+          </p:cNvPr>
+          <p:cNvPicPr>
+            <a:picLocks noGrp="1" noChangeAspect="1"/>
+          </p:cNvPicPr>
+          <p:nvPr>
+            <p:ph idx="1"/>
+          </p:nvPr>
+        </p:nvPicPr>
+        <p:blipFill>
+          <a:blip r:embed="rId2">
+            <a:extLst>
+              <a:ext uri="{28A0092B-C50C-407E-A947-70E740481C1C}">
+                <a14:useLocalDpi xmlns:a14="http://schemas.microsoft.com/office/drawing/2010/main" val="0"/>
+              </a:ext>
+            </a:extLst>
+          </a:blip>
+          <a:stretch>
+            <a:fillRect/>
+          </a:stretch>
+        </p:blipFill>
+        <p:spPr>
+          <a:xfrm>
+            <a:off x="4287413" y="74319"/>
+            <a:ext cx="5142915" cy="6709357"/>
+          </a:xfrm>
+        </p:spPr>
+      </p:pic>
     </p:spTree>
     <p:extLst>
       <p:ext uri="{BB962C8B-B14F-4D97-AF65-F5344CB8AC3E}">

</xml_diff>

<commit_message>
Modifica Presentazione gruppo Majo - Food Alchemy.pptx
</commit_message>
<xml_diff>
--- a/documentazione/Presentazione gruppo Majo - Food Alchemy.pptx
+++ b/documentazione/Presentazione gruppo Majo - Food Alchemy.pptx
@@ -261,7 +261,7 @@
           <a:p>
             <a:fld id="{27026B27-F439-4400-84D8-562DFEFE8515}" type="datetimeFigureOut">
               <a:rPr lang="it-IT" smtClean="0"/>
-              <a:t>04/02/2024</a:t>
+              <a:t>05/02/2024</a:t>
             </a:fld>
             <a:endParaRPr lang="it-IT"/>
           </a:p>
@@ -459,7 +459,7 @@
           <a:p>
             <a:fld id="{27026B27-F439-4400-84D8-562DFEFE8515}" type="datetimeFigureOut">
               <a:rPr lang="it-IT" smtClean="0"/>
-              <a:t>04/02/2024</a:t>
+              <a:t>05/02/2024</a:t>
             </a:fld>
             <a:endParaRPr lang="it-IT"/>
           </a:p>
@@ -667,7 +667,7 @@
           <a:p>
             <a:fld id="{27026B27-F439-4400-84D8-562DFEFE8515}" type="datetimeFigureOut">
               <a:rPr lang="it-IT" smtClean="0"/>
-              <a:t>04/02/2024</a:t>
+              <a:t>05/02/2024</a:t>
             </a:fld>
             <a:endParaRPr lang="it-IT"/>
           </a:p>
@@ -865,7 +865,7 @@
           <a:p>
             <a:fld id="{27026B27-F439-4400-84D8-562DFEFE8515}" type="datetimeFigureOut">
               <a:rPr lang="it-IT" smtClean="0"/>
-              <a:t>04/02/2024</a:t>
+              <a:t>05/02/2024</a:t>
             </a:fld>
             <a:endParaRPr lang="it-IT"/>
           </a:p>
@@ -1140,7 +1140,7 @@
           <a:p>
             <a:fld id="{27026B27-F439-4400-84D8-562DFEFE8515}" type="datetimeFigureOut">
               <a:rPr lang="it-IT" smtClean="0"/>
-              <a:t>04/02/2024</a:t>
+              <a:t>05/02/2024</a:t>
             </a:fld>
             <a:endParaRPr lang="it-IT"/>
           </a:p>
@@ -1405,7 +1405,7 @@
           <a:p>
             <a:fld id="{27026B27-F439-4400-84D8-562DFEFE8515}" type="datetimeFigureOut">
               <a:rPr lang="it-IT" smtClean="0"/>
-              <a:t>04/02/2024</a:t>
+              <a:t>05/02/2024</a:t>
             </a:fld>
             <a:endParaRPr lang="it-IT"/>
           </a:p>
@@ -1817,7 +1817,7 @@
           <a:p>
             <a:fld id="{27026B27-F439-4400-84D8-562DFEFE8515}" type="datetimeFigureOut">
               <a:rPr lang="it-IT" smtClean="0"/>
-              <a:t>04/02/2024</a:t>
+              <a:t>05/02/2024</a:t>
             </a:fld>
             <a:endParaRPr lang="it-IT"/>
           </a:p>
@@ -1958,7 +1958,7 @@
           <a:p>
             <a:fld id="{27026B27-F439-4400-84D8-562DFEFE8515}" type="datetimeFigureOut">
               <a:rPr lang="it-IT" smtClean="0"/>
-              <a:t>04/02/2024</a:t>
+              <a:t>05/02/2024</a:t>
             </a:fld>
             <a:endParaRPr lang="it-IT"/>
           </a:p>
@@ -2071,7 +2071,7 @@
           <a:p>
             <a:fld id="{27026B27-F439-4400-84D8-562DFEFE8515}" type="datetimeFigureOut">
               <a:rPr lang="it-IT" smtClean="0"/>
-              <a:t>04/02/2024</a:t>
+              <a:t>05/02/2024</a:t>
             </a:fld>
             <a:endParaRPr lang="it-IT"/>
           </a:p>
@@ -2382,7 +2382,7 @@
           <a:p>
             <a:fld id="{27026B27-F439-4400-84D8-562DFEFE8515}" type="datetimeFigureOut">
               <a:rPr lang="it-IT" smtClean="0"/>
-              <a:t>04/02/2024</a:t>
+              <a:t>05/02/2024</a:t>
             </a:fld>
             <a:endParaRPr lang="it-IT"/>
           </a:p>
@@ -2670,7 +2670,7 @@
           <a:p>
             <a:fld id="{27026B27-F439-4400-84D8-562DFEFE8515}" type="datetimeFigureOut">
               <a:rPr lang="it-IT" smtClean="0"/>
-              <a:t>04/02/2024</a:t>
+              <a:t>05/02/2024</a:t>
             </a:fld>
             <a:endParaRPr lang="it-IT"/>
           </a:p>
@@ -2911,7 +2911,7 @@
           <a:p>
             <a:fld id="{27026B27-F439-4400-84D8-562DFEFE8515}" type="datetimeFigureOut">
               <a:rPr lang="it-IT" smtClean="0"/>
-              <a:t>04/02/2024</a:t>
+              <a:t>05/02/2024</a:t>
             </a:fld>
             <a:endParaRPr lang="it-IT"/>
           </a:p>
@@ -3414,8 +3414,8 @@
         </p:nvSpPr>
         <p:spPr>
           <a:xfrm>
-            <a:off x="6194716" y="739978"/>
-            <a:ext cx="5334930" cy="3004145"/>
+            <a:off x="5998128" y="739978"/>
+            <a:ext cx="5531518" cy="3004145"/>
           </a:xfrm>
         </p:spPr>
         <p:txBody>
@@ -3426,7 +3426,9 @@
           <a:p>
             <a:pPr algn="r"/>
             <a:r>
-              <a:rPr lang="en-US" dirty="0"/>
+              <a:rPr lang="en-US" dirty="0">
+                <a:latin typeface="Fredoka One" panose="02000000000000000000" pitchFamily="2" charset="0"/>
+              </a:rPr>
               <a:t>Food Alchemy</a:t>
             </a:r>
           </a:p>
@@ -3462,66 +3464,71 @@
           <a:p>
             <a:pPr algn="r"/>
             <a:r>
-              <a:rPr lang="en-US" sz="2200" dirty="0"/>
+              <a:rPr lang="en-US" sz="1800" dirty="0">
+                <a:latin typeface="Fredoka One" panose="02000000000000000000" pitchFamily="2" charset="0"/>
+              </a:rPr>
               <a:t>Cambianica Riccardo 865877</a:t>
             </a:r>
           </a:p>
           <a:p>
             <a:pPr algn="r"/>
             <a:r>
-              <a:rPr lang="en-US" sz="2200" dirty="0"/>
+              <a:rPr lang="en-US" sz="1800" dirty="0">
+                <a:latin typeface="Fredoka One" panose="02000000000000000000" pitchFamily="2" charset="0"/>
+              </a:rPr>
               <a:t>Dolan Radu 866267</a:t>
             </a:r>
           </a:p>
           <a:p>
             <a:pPr algn="r"/>
             <a:r>
-              <a:rPr lang="en-US" sz="2200" dirty="0" err="1"/>
+              <a:rPr lang="en-US" sz="1800" dirty="0" err="1">
+                <a:latin typeface="Fredoka One" panose="02000000000000000000" pitchFamily="2" charset="0"/>
+              </a:rPr>
               <a:t>Luzzana</a:t>
             </a:r>
             <a:r>
-              <a:rPr lang="en-US" sz="2200" dirty="0"/>
+              <a:rPr lang="en-US" sz="1800" dirty="0">
+                <a:latin typeface="Fredoka One" panose="02000000000000000000" pitchFamily="2" charset="0"/>
+              </a:rPr>
               <a:t> Nicola 866087</a:t>
             </a:r>
           </a:p>
           <a:p>
             <a:pPr algn="r"/>
             <a:r>
-              <a:rPr lang="en-US" sz="2200" dirty="0"/>
+              <a:rPr lang="en-US" sz="1800" dirty="0">
+                <a:latin typeface="Fredoka One" panose="02000000000000000000" pitchFamily="2" charset="0"/>
+              </a:rPr>
               <a:t>Singh </a:t>
             </a:r>
             <a:r>
-              <a:rPr lang="en-US" sz="2200" dirty="0" err="1"/>
+              <a:rPr lang="en-US" sz="1800" dirty="0" err="1">
+                <a:latin typeface="Fredoka One" panose="02000000000000000000" pitchFamily="2" charset="0"/>
+              </a:rPr>
               <a:t>Probjot</a:t>
             </a:r>
             <a:r>
-              <a:rPr lang="en-US" sz="2200" dirty="0"/>
+              <a:rPr lang="en-US" sz="1800" dirty="0">
+                <a:latin typeface="Fredoka One" panose="02000000000000000000" pitchFamily="2" charset="0"/>
+              </a:rPr>
               <a:t> 869434</a:t>
             </a:r>
           </a:p>
           <a:p>
             <a:pPr algn="r"/>
             <a:r>
-              <a:rPr lang="en-US" sz="2200" dirty="0" err="1"/>
+              <a:rPr lang="en-US" sz="1800" dirty="0" err="1">
+                <a:latin typeface="Fredoka One" panose="02000000000000000000" pitchFamily="2" charset="0"/>
+              </a:rPr>
               <a:t>Vecchi</a:t>
             </a:r>
             <a:r>
-              <a:rPr lang="en-US" sz="2200" dirty="0"/>
+              <a:rPr lang="en-US" sz="1800" dirty="0">
+                <a:latin typeface="Fredoka One" panose="02000000000000000000" pitchFamily="2" charset="0"/>
+              </a:rPr>
               <a:t> Lorenzo 865932</a:t>
             </a:r>
-          </a:p>
-          <a:p>
-            <a:pPr indent="-228600">
-              <a:buFont typeface="Arial" panose="020B0604020202020204" pitchFamily="34" charset="0"/>
-              <a:buChar char="•"/>
-            </a:pPr>
-            <a:endParaRPr lang="en-US" sz="2200" dirty="0"/>
-          </a:p>
-          <a:p>
-            <a:pPr indent="-228600">
-              <a:buFont typeface="Arial" panose="020B0604020202020204" pitchFamily="34" charset="0"/>
-              <a:buChar char="•"/>
-            </a:pPr>
             <a:endParaRPr lang="en-US" sz="2200" dirty="0"/>
           </a:p>
         </p:txBody>
@@ -4905,10 +4912,11 @@
           <a:lstStyle/>
           <a:p>
             <a:r>
-              <a:rPr lang="it-IT" sz="3600" dirty="0">
+              <a:rPr lang="it-IT" sz="2800" dirty="0">
                 <a:solidFill>
                   <a:srgbClr val="FFFFFF"/>
                 </a:solidFill>
+                <a:latin typeface="Fredoka One" panose="02000000000000000000" pitchFamily="2" charset="0"/>
               </a:rPr>
               <a:t>FUNZIONALITA’</a:t>
             </a:r>
@@ -5279,8 +5287,8 @@
         </p:nvSpPr>
         <p:spPr>
           <a:xfrm>
-            <a:off x="686834" y="1153572"/>
-            <a:ext cx="3200400" cy="4461163"/>
+            <a:off x="558165" y="1153572"/>
+            <a:ext cx="3329069" cy="4461163"/>
           </a:xfrm>
         </p:spPr>
         <p:txBody>
@@ -5290,10 +5298,11 @@
           <a:lstStyle/>
           <a:p>
             <a:r>
-              <a:rPr lang="it-IT" sz="2800" dirty="0">
+              <a:rPr lang="it-IT" sz="2400" dirty="0">
                 <a:solidFill>
                   <a:srgbClr val="FFFFFF"/>
                 </a:solidFill>
+                <a:latin typeface="Fredoka One" panose="02000000000000000000" pitchFamily="2" charset="0"/>
               </a:rPr>
               <a:t>ARCHITETTURA DELL’APPLICAZIONE</a:t>
             </a:r>

</xml_diff>